<commit_message>
Update presentation: 54 tests, per-camera lines, privacy controls, next steps
Co-Authored-By: Claude Sonnet 5.5 <noreply@anthropic.com>
</commit_message>
<xml_diff>
--- a/docs/RetailVision_presentation.pptx
+++ b/docs/RetailVision_presentation.pptx
@@ -116,39 +116,39 @@
   <p:extLst>
     <p:ext uri="{521415D9-36F7-43E2-AB2F-B90AF26B5E84}">
       <p14:sectionLst xmlns:p14="http://schemas.microsoft.com/office/powerpoint/2010/main">
-        <p14:section name="Opening" id="{74b637d0-f8f1-6b1c-1e50-9808abf32434}">
+        <p14:section name="Opening" id="{f2143fbe-2a7b-db73-01ab-a917b4883e28}">
           <p14:sldIdLst>
             <p14:sldId id="256"/>
           </p14:sldIdLst>
         </p14:section>
-        <p14:section name="Idea" id="{0e31d7ec-5dd2-aa04-02c6-f22bb74ef2e3}">
+        <p14:section name="Idea" id="{947cc86a-ad30-315d-6746-b66e11953c6e}">
           <p14:sldIdLst>
             <p14:sldId id="257"/>
           </p14:sldIdLst>
         </p14:section>
-        <p14:section name="How it works" id="{4fe78d61-1ce5-c69b-9d70-b63c7e5a29f9}">
+        <p14:section name="How it works" id="{1f44d05f-2d36-47dd-3f95-41c1e9ed2b34}">
           <p14:sldIdLst>
             <p14:sldId id="258"/>
           </p14:sldIdLst>
         </p14:section>
-        <p14:section name="Demo" id="{2ec562de-ffe4-5367-59d8-bf6f21b7c8e7}">
+        <p14:section name="Demo" id="{27c5e9d8-9f3d-b4dc-fc07-9f0ecb2b9deb}">
           <p14:sldIdLst>
             <p14:sldId id="259"/>
             <p14:sldId id="261"/>
             <p14:sldId id="262"/>
           </p14:sldIdLst>
         </p14:section>
-        <p14:section name="Results" id="{3c0a8093-791a-ddfe-a12c-991e7ce7b016}">
+        <p14:section name="Results" id="{089cce37-6d46-a3b5-4953-bb1f82dcc700}">
           <p14:sldIdLst>
             <p14:sldId id="260"/>
           </p14:sldIdLst>
         </p14:section>
-        <p14:section name="Findings" id="{aa3c090b-524b-e15d-1bac-b07c5850b8d1}">
+        <p14:section name="Findings" id="{7b8f157d-ca55-6fab-da68-4410d93248b7}">
           <p14:sldIdLst>
             <p14:sldId id="263"/>
           </p14:sldIdLst>
         </p14:section>
-        <p14:section name="Next" id="{3ab3bb57-3570-b4a7-91f3-86be07660d51}">
+        <p14:section name="Next" id="{b06cdb3d-acc3-8292-da72-cc06f7808b70}">
           <p14:sldIdLst>
             <p14:sldId id="264"/>
             <p14:sldId id="265"/>
@@ -2768,7 +2768,7 @@
                 <a:ea typeface="Cambria" pitchFamily="34" charset="-122"/>
                 <a:cs typeface="Cambria" pitchFamily="34" charset="-120"/>
               </a:rPr>
-              <a:t>18</a:t>
+              <a:t>54</a:t>
             </a:r>
             <a:endParaRPr lang="en-US" sz="5400" dirty="0"/>
           </a:p>
@@ -5626,7 +5626,7 @@
                   <a:schemeClr val="tx1"/>
                 </a:solidFill>
               </a:rPr>
-              <a:t>Upload a clip and it runs as a background job</a:t>
+              <a:t>Upload a clip: it runs as a background job that survives restarts</a:t>
             </a:r>
             <a:endParaRPr lang="en-US" sz="1800" dirty="0"/>
           </a:p>
@@ -5681,6 +5681,24 @@
                 </a:solidFill>
               </a:rPr>
               <a:t>Shopper behaviour groups: passer-by, browser, engaged</a:t>
+            </a:r>
+            <a:endParaRPr lang="en-US" sz="1800" dirty="0"/>
+          </a:p>
+          <a:p>
+            <a:pPr marL="342900" indent="-342900">
+              <a:spcAft>
+                <a:spcPts val="1200"/>
+              </a:spcAft>
+              <a:buSzPct val="100000"/>
+              <a:buChar char="•"/>
+            </a:pPr>
+            <a:r>
+              <a:rPr lang="en-US" sz="1800" dirty="0">
+                <a:solidFill>
+                  <a:schemeClr val="tx1"/>
+                </a:solidFill>
+              </a:rPr>
+              <a:t>Draw counting lines per camera, set retention, and delete data</a:t>
             </a:r>
             <a:endParaRPr lang="en-US" sz="1800" dirty="0"/>
           </a:p>
@@ -8109,7 +8127,7 @@
                   <a:schemeClr val="tx2"/>
                 </a:solidFill>
               </a:rPr>
-              <a:t>Entrance-line setup screen, user accounts, longer-video handling</a:t>
+              <a:t>Per-user accounts, HTTPS, continuous live streaming on a real camera</a:t>
             </a:r>
             <a:endParaRPr lang="en-US" sz="1400" dirty="0"/>
           </a:p>

</xml_diff>

<commit_message>
Complete local pass: no arbitrary default line, analyst guards, honest benchmark
Camera with no saved line reports no crossings (UI says No line set). Analyst gains
deterministic guards for invented zone literals, missing segment filter, impossible enum
values, plus held-out benchmark (unbiased 92% lenient before the last guard). Docs list known
limits; deck numbers refreshed. 72 tests.

Co-Authored-By: Claude Sonnet 5.5 <noreply@anthropic.com>
</commit_message>
<xml_diff>
--- a/docs/RetailVision_presentation.pptx
+++ b/docs/RetailVision_presentation.pptx
@@ -116,39 +116,39 @@
   <p:extLst>
     <p:ext uri="{521415D9-36F7-43E2-AB2F-B90AF26B5E84}">
       <p14:sectionLst xmlns:p14="http://schemas.microsoft.com/office/powerpoint/2010/main">
-        <p14:section name="Opening" id="{f2143fbe-2a7b-db73-01ab-a917b4883e28}">
+        <p14:section name="Opening" id="{8e61a08e-3967-d905-8223-a168f69f41e1}">
           <p14:sldIdLst>
             <p14:sldId id="256"/>
           </p14:sldIdLst>
         </p14:section>
-        <p14:section name="Idea" id="{947cc86a-ad30-315d-6746-b66e11953c6e}">
+        <p14:section name="Idea" id="{320da18c-a1e8-3be5-5a11-45e03978093a}">
           <p14:sldIdLst>
             <p14:sldId id="257"/>
           </p14:sldIdLst>
         </p14:section>
-        <p14:section name="How it works" id="{1f44d05f-2d36-47dd-3f95-41c1e9ed2b34}">
+        <p14:section name="How it works" id="{eac2756d-b96d-c8a8-62f8-32782a95670b}">
           <p14:sldIdLst>
             <p14:sldId id="258"/>
           </p14:sldIdLst>
         </p14:section>
-        <p14:section name="Demo" id="{27c5e9d8-9f3d-b4dc-fc07-9f0ecb2b9deb}">
+        <p14:section name="Demo" id="{2a22367b-bae7-73d8-4758-7f0e41140710}">
           <p14:sldIdLst>
             <p14:sldId id="259"/>
             <p14:sldId id="261"/>
             <p14:sldId id="262"/>
           </p14:sldIdLst>
         </p14:section>
-        <p14:section name="Results" id="{089cce37-6d46-a3b5-4953-bb1f82dcc700}">
+        <p14:section name="Results" id="{e6c3d953-f1bd-03d6-62a6-35b31e46226e}">
           <p14:sldIdLst>
             <p14:sldId id="260"/>
           </p14:sldIdLst>
         </p14:section>
-        <p14:section name="Findings" id="{7b8f157d-ca55-6fab-da68-4410d93248b7}">
+        <p14:section name="Findings" id="{ff7f5120-3731-d1e7-accc-16744a5607fb}">
           <p14:sldIdLst>
             <p14:sldId id="263"/>
           </p14:sldIdLst>
         </p14:section>
-        <p14:section name="Next" id="{b06cdb3d-acc3-8292-da72-cc06f7808b70}">
+        <p14:section name="Next" id="{c74bc607-f96b-397f-e9f3-455d07056e34}">
           <p14:sldIdLst>
             <p14:sldId id="264"/>
             <p14:sldId id="265"/>
@@ -2768,7 +2768,7 @@
                 <a:ea typeface="Cambria" pitchFamily="34" charset="-122"/>
                 <a:cs typeface="Cambria" pitchFamily="34" charset="-120"/>
               </a:rPr>
-              <a:t>54</a:t>
+              <a:t>72</a:t>
             </a:r>
             <a:endParaRPr lang="en-US" sz="5400" dirty="0"/>
           </a:p>
@@ -2804,7 +2804,7 @@
                   <a:schemeClr val="bg1"/>
                 </a:solidFill>
               </a:rPr>
-              <a:t>automated tests, CI passing</a:t>
+              <a:t>automated tests, all passing</a:t>
             </a:r>
             <a:endParaRPr lang="en-US" sz="1800" dirty="0"/>
           </a:p>
@@ -5418,7 +5418,7 @@
                 <a:ea typeface="Cambria" pitchFamily="34" charset="-122"/>
                 <a:cs typeface="Cambria" pitchFamily="34" charset="-120"/>
               </a:rPr>
-              <a:t>27/30</a:t>
+              <a:t>~90%</a:t>
             </a:r>
             <a:endParaRPr lang="en-US" sz="4800" dirty="0"/>
           </a:p>
@@ -5454,7 +5454,7 @@
                   <a:schemeClr val="tx2"/>
                 </a:solidFill>
               </a:rPr>
-              <a:t>test questions answered correctly by the local analyst</a:t>
+              <a:t>of unseen-wording questions answered correctly by the local analyst</a:t>
             </a:r>
             <a:endParaRPr lang="en-US" sz="1400" dirty="0"/>
           </a:p>

</xml_diff>

<commit_message>
Update deck with measured crossing, bag and forecast results
Co-Authored-By: Claude Sonnet 5.5 <noreply@anthropic.com>
</commit_message>
<xml_diff>
--- a/docs/RetailVision_presentation.pptx
+++ b/docs/RetailVision_presentation.pptx
@@ -116,39 +116,39 @@
   <p:extLst>
     <p:ext uri="{521415D9-36F7-43E2-AB2F-B90AF26B5E84}">
       <p14:sectionLst xmlns:p14="http://schemas.microsoft.com/office/powerpoint/2010/main">
-        <p14:section name="Opening" id="{8e61a08e-3967-d905-8223-a168f69f41e1}">
+        <p14:section name="Opening" id="{c26bab2b-9f54-9cf5-730c-d90a801976ad}">
           <p14:sldIdLst>
             <p14:sldId id="256"/>
           </p14:sldIdLst>
         </p14:section>
-        <p14:section name="Idea" id="{320da18c-a1e8-3be5-5a11-45e03978093a}">
+        <p14:section name="Idea" id="{86a1ab7c-d3fb-69b5-cb0d-220b4552b25c}">
           <p14:sldIdLst>
             <p14:sldId id="257"/>
           </p14:sldIdLst>
         </p14:section>
-        <p14:section name="How it works" id="{eac2756d-b96d-c8a8-62f8-32782a95670b}">
+        <p14:section name="How it works" id="{1dd646a8-bf60-6977-e4cd-507842a294ad}">
           <p14:sldIdLst>
             <p14:sldId id="258"/>
           </p14:sldIdLst>
         </p14:section>
-        <p14:section name="Demo" id="{2a22367b-bae7-73d8-4758-7f0e41140710}">
+        <p14:section name="Demo" id="{b2041aa8-986e-1170-0015-1e7a68732dc8}">
           <p14:sldIdLst>
             <p14:sldId id="259"/>
             <p14:sldId id="261"/>
             <p14:sldId id="262"/>
           </p14:sldIdLst>
         </p14:section>
-        <p14:section name="Results" id="{e6c3d953-f1bd-03d6-62a6-35b31e46226e}">
+        <p14:section name="Results" id="{770cd4c0-1748-d127-a20c-4570ede9e6a4}">
           <p14:sldIdLst>
             <p14:sldId id="260"/>
           </p14:sldIdLst>
         </p14:section>
-        <p14:section name="Findings" id="{ff7f5120-3731-d1e7-accc-16744a5607fb}">
+        <p14:section name="Findings" id="{1013d79d-153d-6d60-ab8c-13526b71a5f9}">
           <p14:sldIdLst>
             <p14:sldId id="263"/>
           </p14:sldIdLst>
         </p14:section>
-        <p14:section name="Next" id="{c74bc607-f96b-397f-e9f3-455d07056e34}">
+        <p14:section name="Next" id="{a0fc3c66-7fc7-b20b-94c4-58f825c3988a}">
           <p14:sldIdLst>
             <p14:sldId id="264"/>
             <p14:sldId id="265"/>
@@ -2768,7 +2768,7 @@
                 <a:ea typeface="Cambria" pitchFamily="34" charset="-122"/>
                 <a:cs typeface="Cambria" pitchFamily="34" charset="-120"/>
               </a:rPr>
-              <a:t>72</a:t>
+              <a:t>84</a:t>
             </a:r>
             <a:endParaRPr lang="en-US" sz="5400" dirty="0"/>
           </a:p>
@@ -6661,7 +6661,7 @@
                   <a:schemeClr val="accent3"/>
                 </a:solidFill>
               </a:rPr>
-              <a:t>Staff / bag labels</a:t>
+              <a:t>Bag and staff labels</a:t>
             </a:r>
             <a:endParaRPr lang="en-US" sz="2200" dirty="0"/>
           </a:p>
@@ -6733,7 +6733,7 @@
                   <a:schemeClr val="tx1"/>
                 </a:solidFill>
               </a:rPr>
-              <a:t>CLIP guessed worse than 'nobody has a bag' (accuracy 0.48 to 0.54 vs 0.63) on 90-pixel crops.</a:t>
+              <a:t>Bag check: below baseline on small mall crops, but 74% vs 51% on people 180+ px tall (53 crops). Staff vs customer: never validated.</a:t>
             </a:r>
             <a:endParaRPr lang="en-US" sz="1500" dirty="0"/>
           </a:p>
@@ -6805,7 +6805,7 @@
                   <a:schemeClr val="tx1"/>
                 </a:solidFill>
               </a:rPr>
-              <a:t>Switched off by default; the system says 'unknown' instead of a wrong label.</a:t>
+              <a:t>Bag check only for 180+ px crops and opt-in; staff label stays off.</a:t>
             </a:r>
             <a:endParaRPr lang="en-US" sz="1500" dirty="0"/>
           </a:p>
@@ -6868,7 +6868,7 @@
                   <a:schemeClr val="accent3"/>
                 </a:solidFill>
               </a:rPr>
-              <a:t>Unique visitors</a:t>
+              <a:t>Crossings and visitors</a:t>
             </a:r>
             <a:endParaRPr lang="en-US" sz="2200" dirty="0"/>
           </a:p>
@@ -6940,7 +6940,7 @@
                   <a:schemeClr val="tx1"/>
                 </a:solidFill>
               </a:rPr>
-              <a:t>Identity fragments across the crowd, so the count for one 200 s clip could be anywhere from about 230 to 350.</a:t>
+              <a:t>Hand-labelled entrance clip: precision 70%, recall 71%. Reported 57 vs ~52 real, because errors offset. People tracked is inflated by ID switches.</a:t>
             </a:r>
             <a:endParaRPr lang="en-US" sz="1500" dirty="0"/>
           </a:p>
@@ -7012,7 +7012,7 @@
                   <a:schemeClr val="tx1"/>
                 </a:solidFill>
               </a:rPr>
-              <a:t>Report occupancy and entrance crossings instead; call the number an estimate.</a:t>
+              <a:t>Report crossings as an estimate, cancel flip-flops, keep people tracked labelled an estimate.</a:t>
             </a:r>
             <a:endParaRPr lang="en-US" sz="1500" dirty="0"/>
           </a:p>
@@ -7075,7 +7075,7 @@
                   <a:schemeClr val="accent3"/>
                 </a:solidFill>
               </a:rPr>
-              <a:t>LSTM forecast</a:t>
+              <a:t>Forecast</a:t>
             </a:r>
             <a:endParaRPr lang="en-US" sz="2200" dirty="0"/>
           </a:p>
@@ -7147,7 +7147,7 @@
                   <a:schemeClr val="tx1"/>
                 </a:solidFill>
               </a:rPr>
-              <a:t>On 17 minutes of data it only tied 'same as last value'. An LSTM needs days of history.</a:t>
+              <a:t>On 17 minutes of data the LSTM only tied 'same as last value'. It needs days of history, which we do not have.</a:t>
             </a:r>
             <a:endParaRPr lang="en-US" sz="1500" dirty="0"/>
           </a:p>
@@ -7219,7 +7219,7 @@
                   <a:schemeClr val="tx1"/>
                 </a:solidFill>
               </a:rPr>
-              <a:t>Forecast backtests itself and falls back to the baseline when it does not win.</a:t>
+              <a:t>Backtests LSTM, last value and same-hour-yesterday and uses the winner; a monitor collects the data.</a:t>
             </a:r>
             <a:endParaRPr lang="en-US" sz="1500" dirty="0"/>
           </a:p>

</xml_diff>